<commit_message>
Add the full build-cost model and rebuild the slide on real complex circuits
The slide now shows a 16-cell circuit with a cell properties panel and a
comparison of two circuits, with no overlap. Rubric text follows the owner's voice
profile. The build cost is estimated bottom-up from the product vision and cross-
checked with COCOMO II. Compare now follows Circuit view and uses the wider page.

Co-Authored-By: Claude Opus 5.5 <noreply@anthropic.com>
</commit_message>
<xml_diff>
--- a/reports/slide_v4/VOLT-FORGE_Round1_Slide.pptx
+++ b/reports/slide_v4/VOLT-FORGE_Round1_Slide.pptx
@@ -546,6 +546,16 @@
           <a:p>
             <a:r>
               <a:t>Market: AISHE 2021-22. The price of Rs 50,000 a lab and 5% reach are assumptions, and counts do not show willingness to pay.</a:t>
+            </a:r>
+          </a:p>
+          <a:p>
+            <a:r>
+              <a:t>Build cost: about Rs 35 crore over 3 years and 100.5 person-years for the full product vision. An estimate from sourced salary rates and assumed staffing, cross-checked with COCOMO II. See reports/build_cost_v1/BUILD_COST.md. AspenTech fiscal 2024 R&amp;D was US$206.1 million.</a:t>
+            </a:r>
+          </a:p>
+          <a:p>
+            <a:r>
+              <a:t>Screens: real designs in the app. The 16-cell and 12-cell modules are examples of what it can handle, not the recommended design.</a:t>
             </a:r>
           </a:p>
         </p:txBody>
@@ -6761,7 +6771,7 @@
       </p:pic>
       <p:pic>
         <p:nvPicPr>
-          <p:cNvPr id="8" name="VOLT-FORGE Round 1 slide" descr="VOLT-FORGE: the seven rubric criteria around the working app, with its canvas and test verdict at the centre."/>
+          <p:cNvPr id="8" name="VOLT-FORGE Round 1 slide" descr="VOLT-FORGE: the seven rubric criteria around the working app, showing a 16-cell circuit with a cell properties panel, and a comparison of two circuits."/>
           <p:cNvPicPr>
             <a:picLocks noChangeAspect="1"/>
           </p:cNvPicPr>

</xml_diff>

<commit_message>
Tell the slide as one story and show the full compare table
Rubric blocks now follow one user from problem to answer, simple first and then
technical. The KPIs are 4,006 what-if runs, 42 overloads caught and a measured
10-minute run in about 3 seconds. Compare keeps its 12 result rows in two compact
tables at wide widths.

Co-Authored-By: Claude Opus 5.5 <noreply@anthropic.com>
</commit_message>
<xml_diff>
--- a/reports/slide_v4/VOLT-FORGE_Round1_Slide.pptx
+++ b/reports/slide_v4/VOLT-FORGE_Round1_Slide.pptx
@@ -551,6 +551,11 @@
           <a:p>
             <a:r>
               <a:t>Build cost: about Rs 35 crore over 3 years and 100.5 person-years for the full product vision. An estimate from sourced salary rates and assumed staffing, cross-checked with COCOMO II. See reports/build_cost_v1/BUILD_COST.md. AspenTech fiscal 2024 R&amp;D was US$206.1 million.</a:t>
+            </a:r>
+          </a:p>
+          <a:p>
+            <a:r>
+              <a:t>KPIs: 42 of 4,006 study runs were refused because a cell would have exceeded 7.275 A. A 10-minute run of the 16-cell module took a median 3.07 s on Apple M1, 8 GB, Darwin.</a:t>
             </a:r>
           </a:p>
           <a:p>

</xml_diff>

<commit_message>
Simplify the slide and show real 4 vs 2 cell designs
Use the Pi circuit and its compare table in the centre, count the data
KPIs from project records, and plain-word the feasibility text. Hide
compare rows that add nothing and print whole-number differences.

Co-Authored-By: Claude Opus 5.5 <noreply@anthropic.com>
</commit_message>
<xml_diff>
--- a/reports/slide_v4/VOLT-FORGE_Round1_Slide.pptx
+++ b/reports/slide_v4/VOLT-FORGE_Round1_Slide.pptx
@@ -555,12 +555,12 @@
           </a:p>
           <a:p>
             <a:r>
-              <a:t>KPIs: 42 of 4,006 study runs were refused because a cell would have exceeded 7.275 A. A 10-minute run of the 16-cell module took a median 3.07 s on Apple M1, 8 GB, Darwin.</a:t>
-            </a:r>
-          </a:p>
-          <a:p>
-            <a:r>
-              <a:t>Screens: real designs in the app. The 16-cell and 12-cell modules are examples of what it can handle, not the recommended design.</a:t>
+              <a:t>KPIs: 54 module experiments and 194 data files in the Piombo et al. dataset, each file integrity-checked. 9 records are reserved for a final assessment and were never opened: 3 module tests and 6 Samsung cell records.</a:t>
+            </a:r>
+          </a:p>
+          <a:p>
+            <a:r>
+              <a:t>Screens: real designs in the app. The table compares the 4-cell starting design with the 2-cell design under the same 8.42 A load.</a:t>
             </a:r>
           </a:p>
         </p:txBody>
@@ -6776,7 +6776,7 @@
       </p:pic>
       <p:pic>
         <p:nvPicPr>
-          <p:cNvPr id="8" name="VOLT-FORGE Round 1 slide" descr="VOLT-FORGE: the seven rubric criteria around the working app, showing a 16-cell circuit with a cell properties panel, and a comparison of two circuits."/>
+          <p:cNvPr id="8" name="VOLT-FORGE Round 1 slide" descr="VOLT-FORGE: the seven rubric criteria around the working app, showing the 4-cell Pi circuit with a cell properties panel, and a comparison of the 4-cell and 2-cell designs."/>
           <p:cNvPicPr>
             <a:picLocks noChangeAspect="1"/>
           </p:cNvPicPr>

</xml_diff>

<commit_message>
Rebuild every output on the locked code
The full 4,006-case rerun matched the earlier study with no change in any
of 19,820 numbers. The slide, PPTX, PDF, appendix and demo now come from
that run, and the screens show the study's own recommended design.

Co-Authored-By: Claude Opus 5.5 <noreply@anthropic.com>
</commit_message>
<xml_diff>
--- a/reports/slide_v4/VOLT-FORGE_Round1_Slide.pptx
+++ b/reports/slide_v4/VOLT-FORGE_Round1_Slide.pptx
@@ -530,12 +530,27 @@
           </a:p>
           <a:p>
             <a:r>
-              <a:t>Real data: all 12 pre-declared comparison cases missed their bands. Sources: Chen et al. 2020 (LG M50, zenodo.4032561) and Piombo et al. 2024 test 28 (M50T, 10.17632/zh58byr53c.2).</a:t>
-            </a:r>
-          </a:p>
-          <a:p>
-            <a:r>
-              <a:t>Not proven: the Geekworm X1206 V2.0 board running on two cells, a real Pi draw, or measured accuracy.</a:t>
+              <a:t>Real data: all 12 pre-declared full-discharge checks missed their bands, on voltage and on temperature. These are 8 measured discharges and 4 sensitivity reruns. Sources: Chen et al. 2020 (LG M50, zenodo.4032561) and Piombo et al. 2024 test 28 (M50T, 10.17632/zh58byr53c.2).</a:t>
+            </a:r>
+          </a:p>
+          <a:p>
+            <a:r>
+              <a:t>Board: Geekworm X1205 2-cell UPS HAT, US$46, 5.1 V at up to 6 A, up to 95% efficiency and a 2.4 V cutoff, from its listing and wiki. Its battery overcurrent threshold is not published.</a:t>
+            </a:r>
+          </a:p>
+          <a:p>
+            <a:r>
+              <a:t>Current shares: Piombo test 28, first 10% of the discharge, measured against simulated, with Hall channels normalised to their own sum. Average error 1.13 points against 2.38 for an equal-share guess, inside the frozen 2.5 point band. The busiest cell was named in 62% of samples against a required 80%, so that part missed. The equal-share comparison was added after the run. This is one test with 3 mOhm links, early in the discharge; later on the error is larger, and the near-zero-link test shared evenly. Over the first 10 minutes, real heating was 0.27 to 1.13 times the model across 8 discharges, also added after the run.</a:t>
+            </a:r>
+          </a:p>
+          <a:p>
+            <a:r>
+              <a:t>Heat: real rises reached 2.27 times the simulated rise. Applied to the 2-cell worst case that gives 42.4 C against the LG 55 C limit. Voltage: the largest error in the Pi's charge range was 0.17 V against a 0.20 V margin.</a:t>
+            </a:r>
+          </a:p>
+          <a:p>
+            <a:r>
+              <a:t>Not proven: a real Pi draw on this board, the board's overcurrent limit, or measured accuracy. Below 10 C the LG limit falls to 2.425 A a cell, so two cells could not carry this load.</a:t>
             </a:r>
           </a:p>
           <a:p>
@@ -550,12 +565,22 @@
           </a:p>
           <a:p>
             <a:r>
+              <a:t>Business: free for students, labs and teams pay, as a hypothesis. Stage one is dataset, results, quality and the lab, Rs 11.0 crore. That is Rs 2.2 crore a year for 5 years, before running costs. 130 labs at Rs 50,000 give Rs 65 lakh, and 31 teams at an assumed Rs 5 lakh give the rest. No customer has seen these prices, and the number of paying teams has not been sized. One seat of MATLAB, Simulink, Simscape and Simscape Battery lists at US$13,180 perpetual, September 2026.</a:t>
+            </a:r>
+          </a:p>
+          <a:p>
+            <a:r>
               <a:t>Build cost: about Rs 35 crore over 3 years and 100.5 person-years for the full product vision. An estimate from sourced salary rates and assumed staffing, cross-checked with COCOMO II. See reports/build_cost_v1/BUILD_COST.md. AspenTech fiscal 2024 R&amp;D was US$206.1 million.</a:t>
             </a:r>
           </a:p>
           <a:p>
             <a:r>
-              <a:t>KPIs: 54 module experiments and 194 data files in the Piombo et al. dataset, each file integrity-checked. 9 records are reserved for a final assessment and were never opened: 3 module tests and 6 Samsung cell records.</a:t>
+              <a:t>Safety and limits: no spare cell, so three cells is the smallest design that survives losing one. 25 W is the supply rating, and below about 21.6 W one cell stays under its limit. Bench safety steps are in the appendix. No user has tried the app yet.</a:t>
+            </a:r>
+          </a:p>
+          <a:p>
+            <a:r>
+              <a:t>KPIs: 54 module experiments in the Piombo et al. dataset, and 194 dataset files checksum-verified, including cell characterisation and calibration files. 9 records are reserved for a final assessment and were never opened: 3 module tests and 6 Samsung cell records.</a:t>
             </a:r>
           </a:p>
           <a:p>

</xml_diff>

<commit_message>
Add the public site and finish the slide for submission
The site plays the demo first, then runs the real engine in the visitor's
browser, with a small server function holding the Gemini key. The slide
gains captions, both links and the team details on the cover.

Co-Authored-By: Claude Opus 5.5 <noreply@anthropic.com>
</commit_message>
<xml_diff>
--- a/reports/slide_v4/VOLT-FORGE_Round1_Slide.pptx
+++ b/reports/slide_v4/VOLT-FORGE_Round1_Slide.pptx
@@ -581,6 +581,11 @@
           <a:p>
             <a:r>
               <a:t>KPIs: 54 module experiments in the Piombo et al. dataset, and 194 dataset files checksum-verified, including cell characterisation and calibration files. 9 records are reserved for a final assessment and were never opened: 3 module tests and 6 Samsung cell records.</a:t>
+            </a:r>
+          </a:p>
+          <a:p>
+            <a:r>
+              <a:t>Link: the site shows the demo video first, then the real engine running in the visitor's browser. The AI uses Gemini through a small server function.</a:t>
             </a:r>
           </a:p>
           <a:p>
@@ -6618,7 +6623,15 @@
                   </a:outerShdw>
                 </a:effectLst>
               </a:rPr>
-              <a:t>Team Details</a:t>
+              <a:t>Team StratWise</a:t>
+            </a:r>
+          </a:p>
+          <a:p>
+            <a:pPr>
+              <a:defRPr sz="1800" b="0"/>
+            </a:pPr>
+            <a:r>
+              <a:t>Shubhra Arora, Jai Kaushik, Sanya Bansal</a:t>
             </a:r>
           </a:p>
         </p:txBody>
@@ -6823,6 +6836,92 @@
           </a:prstGeom>
         </p:spPr>
       </p:pic>
+      <p:sp>
+        <p:nvSpPr>
+          <p:cNvPr id="9" name="site link">
+            <a:hlinkClick r:id="rId5"/>
+          </p:cNvPr>
+          <p:cNvSpPr/>
+          <p:nvPr/>
+        </p:nvSpPr>
+        <p:spPr>
+          <a:xfrm>
+            <a:off x="6352480" y="723900"/>
+            <a:ext cx="1339552" cy="190500"/>
+          </a:xfrm>
+          <a:prstGeom prst="rect">
+            <a:avLst/>
+          </a:prstGeom>
+          <a:noFill/>
+          <a:ln>
+            <a:noFill/>
+          </a:ln>
+        </p:spPr>
+        <p:style>
+          <a:lnRef idx="1">
+            <a:schemeClr val="accent1"/>
+          </a:lnRef>
+          <a:fillRef idx="3">
+            <a:schemeClr val="accent1"/>
+          </a:fillRef>
+          <a:effectRef idx="2">
+            <a:schemeClr val="accent1"/>
+          </a:effectRef>
+          <a:fontRef idx="minor">
+            <a:schemeClr val="lt1"/>
+          </a:fontRef>
+        </p:style>
+        <p:txBody>
+          <a:bodyPr rtlCol="0" anchor="ctr"/>
+          <a:lstStyle/>
+          <a:p>
+            <a:pPr algn="ctr"/>
+          </a:p>
+        </p:txBody>
+      </p:sp>
+      <p:sp>
+        <p:nvSpPr>
+          <p:cNvPr id="10" name="appendix link">
+            <a:hlinkClick r:id="rId6"/>
+          </p:cNvPr>
+          <p:cNvSpPr/>
+          <p:nvPr/>
+        </p:nvSpPr>
+        <p:spPr>
+          <a:xfrm>
+            <a:off x="6419254" y="6096000"/>
+            <a:ext cx="1954609" cy="196850"/>
+          </a:xfrm>
+          <a:prstGeom prst="rect">
+            <a:avLst/>
+          </a:prstGeom>
+          <a:noFill/>
+          <a:ln>
+            <a:noFill/>
+          </a:ln>
+        </p:spPr>
+        <p:style>
+          <a:lnRef idx="1">
+            <a:schemeClr val="accent1"/>
+          </a:lnRef>
+          <a:fillRef idx="3">
+            <a:schemeClr val="accent1"/>
+          </a:fillRef>
+          <a:effectRef idx="2">
+            <a:schemeClr val="accent1"/>
+          </a:effectRef>
+          <a:fontRef idx="minor">
+            <a:schemeClr val="lt1"/>
+          </a:fontRef>
+        </p:style>
+        <p:txBody>
+          <a:bodyPr rtlCol="0" anchor="ctr"/>
+          <a:lstStyle/>
+          <a:p>
+            <a:pPr algn="ctr"/>
+          </a:p>
+        </p:txBody>
+      </p:sp>
     </p:spTree>
     <p:extLst>
       <p:ext uri="{BB962C8B-B14F-4D97-AF65-F5344CB8AC3E}">

</xml_diff>